<commit_message>
Review fixes: accurate prep/interruption ranges, failover check count, 15 workflow tool calls, article baselines and status wording, strict zone-B origin check in the handover demo
Co-Authored-By: Claude Opus 5.5 <noreply@anthropic.com>
Claude-Session: https://claude.ai/code/session_01MNBPuHt8REYo463DnF9BtM
</commit_message>
<xml_diff>
--- a/docs/submissions/EdgeGuard_Interim_Report.pptx
+++ b/docs/submissions/EdgeGuard_Interim_Report.pptx
@@ -122,20 +122,20 @@
   <p:extLst>
     <p:ext uri="{521415D9-36F7-43E2-AB2F-B90AF26B5E84}">
       <p14:sectionLst xmlns:p14="http://schemas.microsoft.com/office/powerpoint/2010/main">
-        <p14:section name="Introduction" id="{0ed821e7-1c1a-71f1-d2b0-4db05531ac2e}">
+        <p14:section name="Introduction" id="{b4ce6049-7414-5596-a60e-1745c0466690}">
           <p14:sldIdLst>
             <p14:sldId id="256"/>
             <p14:sldId id="257"/>
           </p14:sldIdLst>
         </p14:section>
-        <p14:section name="Use case" id="{a568a412-942f-5242-435d-16a7c4ea2011}">
+        <p14:section name="Use case" id="{e0795979-85a0-fae5-78f4-8e977187a0a2}">
           <p14:sldIdLst>
             <p14:sldId id="258"/>
             <p14:sldId id="259"/>
             <p14:sldId id="260"/>
           </p14:sldIdLst>
         </p14:section>
-        <p14:section name="Architecture" id="{93568bcc-abda-86f6-8699-cc0498c7a657}">
+        <p14:section name="Architecture" id="{feea18c1-b1dc-cb46-1f04-f7b679b202a5}">
           <p14:sldIdLst>
             <p14:sldId id="261"/>
             <p14:sldId id="262"/>
@@ -144,7 +144,7 @@
             <p14:sldId id="265"/>
           </p14:sldIdLst>
         </p14:section>
-        <p14:section name="Status and plan" id="{c57fa3dc-2eae-fd5a-a37b-ddb0b4a43977}">
+        <p14:section name="Status and plan" id="{bb645876-4624-ca01-c31b-b11b317d56c8}">
           <p14:sldIdLst>
             <p14:sldId id="266"/>
             <p14:sldId id="267"/>
@@ -5397,7 +5397,7 @@
                   <a:schemeClr val="accent2"/>
                 </a:solidFill>
               </a:rPr>
-              <a:t>3–9 ms interruption, 0 samples lost · failover ≈ 0.3 s</a:t>
+              <a:t>3–11 ms interruption, 0 samples lost · failover ≈ 0.3 s</a:t>
             </a:r>
             <a:endParaRPr lang="en-US" sz="1400" dirty="0"/>
           </a:p>
@@ -5667,7 +5667,7 @@
                   <a:schemeClr val="accent2"/>
                 </a:solidFill>
               </a:rPr>
-              <a:t>shift report in 16 tool calls, validated · 9/9 checks</a:t>
+              <a:t>shift report in 15 tool calls, validated · 9/9 checks</a:t>
             </a:r>
             <a:endParaRPr lang="en-US" sz="1400" dirty="0"/>
           </a:p>
@@ -7181,7 +7181,7 @@
                             <a:schemeClr val="tx1"/>
                           </a:solidFill>
                         </a:rPr>
-                        <a:t>SDT flexContainers + SAREF; CSE handover (3–9 ms, 0 lost); FL through oneM2M (2 s error 0.60 → 0.49 m); safety agent over 4 MCP servers</a:t>
+                        <a:t>SDT flexContainers + SAREF; CSE handover (3–11 ms, 0 lost); FL through oneM2M (2 s error 0.60 → 0.49 m); safety agent over 4 MCP servers</a:t>
                       </a:r>
                       <a:endParaRPr lang="en-US" sz="1200" dirty="0"/>
                     </a:p>
@@ -9474,7 +9474,7 @@
                   <a:schemeClr val="tx1"/>
                 </a:solidFill>
               </a:rPr>
-              <a:t>Working end to end on Mobius and ACME. Already built: SDT flexContainer data model with SAREF semantics, CSE handover between zone MN-CSEs (3–9 ms interruption), federated learning through oneM2M, an AI safety agent over MCP. Collisions 100 → 4 in simulation.</a:t>
+              <a:t>Working end to end on Mobius and ACME. Already built: SDT flexContainer data model with SAREF semantics, CSE handover between zone MN-CSEs (3–11 ms interruption), federated learning through oneM2M, an AI safety agent over MCP. Collisions 100 → 4 in simulation.</a:t>
             </a:r>
             <a:endParaRPr lang="en-US" sz="1500" dirty="0"/>
           </a:p>
@@ -11888,7 +11888,7 @@
                           <a:ea typeface="Calibri" pitchFamily="34" charset="-122"/>
                           <a:cs typeface="Calibri" pitchFamily="34" charset="-120"/>
                         </a:rPr>
-                        <a:t>CSE handover between zone MN-CSEs (3–9 ms, 0 lost), active-standby MEC app (0.73 s), D2D fallback</a:t>
+                        <a:t>CSE handover between zone MN-CSEs (3–11 ms, 0 lost), active-standby MEC app (0.73 s), D2D fallback</a:t>
                       </a:r>
                       <a:endParaRPr lang="en-US" sz="1400" dirty="0">
                         <a:latin typeface="Calibri" charset="0"/>

</xml_diff>

<commit_message>
Interim report: article, video and public repo marked done (Oct 11), links on the closing slide
Co-Authored-By: Claude Opus 5.5 <noreply@anthropic.com>
Claude-Session: https://claude.ai/code/session_011rQ9Y5HYSM3z9JeRDnFo1G
</commit_message>
<xml_diff>
--- a/docs/submissions/EdgeGuard_Interim_Report.pptx
+++ b/docs/submissions/EdgeGuard_Interim_Report.pptx
@@ -6655,7 +6655,7 @@
                   <a:schemeClr val="tx1"/>
                 </a:solidFill>
               </a:rPr>
-              <a:t>ESP32 firmware run unmodified against a real CSE in CI; hackster.io draft</a:t>
+              <a:t>ESP32 firmware run unmodified against a real CSE in CI; hackster.io article published</a:t>
             </a:r>
             <a:endParaRPr lang="en-US" sz="1400" dirty="0"/>
           </a:p>
@@ -8724,7 +8724,7 @@
                   <a:schemeClr val="tx1"/>
                 </a:solidFill>
               </a:rPr>
-              <a:t>M5  ESP32 boards, user study, article, video, public repo</a:t>
+              <a:t>M5  ESP32 boards, user study (article, video, repo: done)</a:t>
             </a:r>
             <a:endParaRPr lang="en-US" sz="1200" dirty="0"/>
           </a:p>
@@ -10365,7 +10365,7 @@
                             <a:schemeClr val="tx1"/>
                           </a:solidFill>
                         </a:rPr>
-                        <a:t>ESP32 board demo; user study (10+); hackster.io article; final video; public GitHub</a:t>
+                        <a:t>ESP32 board demo; user study (10+); done Oct 11: hackster.io article, final video, public GitHub</a:t>
                       </a:r>
                       <a:endParaRPr lang="en-US" sz="1200" dirty="0"/>
                     </a:p>
@@ -10481,7 +10481,7 @@
                             <a:schemeClr val="tx1"/>
                           </a:solidFill>
                         </a:rPr>
-                        <a:t>Article published; repo public; video under 3 min</a:t>
+                        <a:t>Done Oct 11: article published, repo public, video 2:34. Open: board demo, user study</a:t>
                       </a:r>
                       <a:endParaRPr lang="en-US" sz="1200" dirty="0"/>
                     </a:p>
@@ -11252,7 +11252,7 @@
         <p:spPr>
           <a:xfrm>
             <a:off x="731520" y="3657600"/>
-            <a:ext cx="8686800" cy="1097280"/>
+            <a:ext cx="8686800" cy="1463040"/>
           </a:xfrm>
           <a:prstGeom prst="rect">
             <a:avLst/>
@@ -11288,6 +11288,34 @@
                 </a:solidFill>
               </a:rPr>
               <a:t>Thank you</a:t>
+            </a:r>
+            <a:endParaRPr lang="en-US" sz="2000" dirty="0"/>
+          </a:p>
+          <a:p>
+            <a:pPr algn="l" indent="0" marL="0">
+              <a:buNone/>
+            </a:pPr>
+            <a:r>
+              <a:rPr lang="en-US" sz="1200" dirty="0">
+                <a:solidFill>
+                  <a:schemeClr val="bg2"/>
+                </a:solidFill>
+              </a:rPr>
+              <a:t>Code github.com/ljw22112/Edgeguard  ·  Video youtu.be/P2JI5ZG6PIg</a:t>
+            </a:r>
+            <a:endParaRPr lang="en-US" sz="2000" dirty="0"/>
+          </a:p>
+          <a:p>
+            <a:pPr algn="l" indent="0" marL="0">
+              <a:buNone/>
+            </a:pPr>
+            <a:r>
+              <a:rPr lang="en-US" sz="1200" dirty="0">
+                <a:solidFill>
+                  <a:schemeClr val="bg2"/>
+                </a:solidFill>
+              </a:rPr>
+              <a:t>Article hackster.io/ahind012/edgeguard-stop-forklift-accidents-before-they-happen-e07309</a:t>
             </a:r>
             <a:endParaRPr lang="en-US" sz="2000" dirty="0"/>
           </a:p>
@@ -11821,7 +11849,7 @@
                   <a:schemeClr val="tx1"/>
                 </a:solidFill>
               </a:rPr>
-              <a:t>Run on the ESTIMED VM and the ETSI Sandbox subscription APIs; MQTT in the ESP32 firmware; ESP32 board demo, user study, hackster.io article, final video, public repository.</a:t>
+              <a:t>Run on the ESTIMED VM and the ETSI Sandbox subscription APIs; MQTT in the ESP32 firmware; ESP32 board demo and user study. Done Oct 11: hackster.io article, final video, public repository.</a:t>
             </a:r>
             <a:endParaRPr lang="en-US" sz="1500" dirty="0"/>
           </a:p>

</xml_diff>